<commit_message>
Remove Route Cost Map placeholder module
The module was never started: no mapping data source was agreed and no
corridor distances were measured, so it could not have been populated
without inventing the numbers it displayed.

Removes tab-2 from MODULE_INFO, NAV_ICONS, serve_layout and the
instructions panel, and deletes placeholder_layout and the
MODULES_IN_DEVELOPMENT mechanism, which had nothing left to mark.

Display numbers shift: what was 6, 7 and 8 is now 5, 6 and 7. Guide
renumbered from 34 slides to 33. Report Section 1.4 now says seven
modules and Section 8.3 carries the route map as further work with the
blocker stated.

Also ignores Office ~$ lock files.
</commit_message>
<xml_diff>
--- a/docs/EV_Dashboard_User_Guide.pptx
+++ b/docs/EV_Dashboard_User_Guide.pptx
@@ -27,7 +27,6 @@
     <p:sldId id="275" r:id="rId21"/>
     <p:sldId id="276" r:id="rId22"/>
     <p:sldId id="277" r:id="rId23"/>
-    <p:sldId id="278" r:id="rId24"/>
     <p:sldId id="279" r:id="rId25"/>
     <p:sldId id="280" r:id="rId26"/>
     <p:sldId id="281" r:id="rId27"/>
@@ -1791,94 +1790,6 @@
             <a:fld id="{F7021451-1387-4CA6-816F-3879F97B5CBC}" type="slidenum">
               <a:rPr lang="en-US"/>
               <a:t>22</a:t>
-            </a:fld>
-            <a:endParaRPr lang="en-US"/>
-          </a:p>
-        </p:txBody>
-      </p:sp>
-    </p:spTree>
-    <p:extLst>
-      <p:ext uri="{BB962C8B-B14F-4D97-AF65-F5344CB8AC3E}">
-        <p14:creationId xmlns:p14="http://schemas.microsoft.com/office/powerpoint/2010/main" val="1024086991"/>
-      </p:ext>
-    </p:extLst>
-  </p:cSld>
-  <p:clrMapOvr>
-    <a:masterClrMapping/>
-  </p:clrMapOvr>
-</p:notes>
-</file>
-
-<file path=ppt/notesSlides/notesSlide23.xml><?xml version="1.0" encoding="utf-8"?>
-<p:notes xmlns:a="http://schemas.openxmlformats.org/drawingml/2006/main" xmlns:r="http://schemas.openxmlformats.org/officeDocument/2006/relationships" xmlns:p="http://schemas.openxmlformats.org/presentationml/2006/main">
-  <p:cSld>
-    <p:spTree>
-      <p:nvGrpSpPr>
-        <p:cNvPr id="1" name=""/>
-        <p:cNvGrpSpPr/>
-        <p:nvPr/>
-      </p:nvGrpSpPr>
-      <p:grpSpPr>
-        <a:xfrm>
-          <a:off x="0" y="0"/>
-          <a:ext cx="0" cy="0"/>
-          <a:chOff x="0" y="0"/>
-          <a:chExt cx="0" cy="0"/>
-        </a:xfrm>
-      </p:grpSpPr>
-      <p:sp>
-        <p:nvSpPr>
-          <p:cNvPr id="2" name="Slide Image Placeholder 1"/>
-          <p:cNvSpPr>
-            <a:spLocks noGrp="1" noRot="1" noChangeAspect="1"/>
-          </p:cNvSpPr>
-          <p:nvPr>
-            <p:ph type="sldImg"/>
-          </p:nvPr>
-        </p:nvSpPr>
-        <p:spPr/>
-      </p:sp>
-      <p:sp>
-        <p:nvSpPr>
-          <p:cNvPr id="3" name="Notes Placeholder 2"/>
-          <p:cNvSpPr>
-            <a:spLocks noGrp="1"/>
-          </p:cNvSpPr>
-          <p:nvPr>
-            <p:ph type="body" idx="1"/>
-          </p:nvPr>
-        </p:nvSpPr>
-        <p:spPr/>
-        <p:txBody>
-          <a:bodyPr/>
-          <a:lstStyle/>
-          <a:p>
-            <a:r>
-              <a:rPr lang="en-US" dirty="0"/>
-              <a:t/>
-            </a:r>
-            <a:endParaRPr lang="en-US" dirty="0"/>
-          </a:p>
-        </p:txBody>
-      </p:sp>
-      <p:sp>
-        <p:nvSpPr>
-          <p:cNvPr id="4" name="Slide Number Placeholder 3"/>
-          <p:cNvSpPr>
-            <a:spLocks noGrp="1"/>
-          </p:cNvSpPr>
-          <p:nvPr>
-            <p:ph type="sldNum" sz="quarter" idx="10"/>
-          </p:nvPr>
-        </p:nvSpPr>
-        <p:spPr/>
-        <p:txBody>
-          <a:bodyPr/>
-          <a:lstStyle/>
-          <a:p>
-            <a:fld id="{F7021451-1387-4CA6-816F-3879F97B5CBC}" type="slidenum">
-              <a:rPr lang="en-US"/>
-              <a:t>23</a:t>
             </a:fld>
             <a:endParaRPr lang="en-US"/>
           </a:p>
@@ -13559,7 +13470,7 @@
                 <a:ea typeface="Calibri" pitchFamily="34" charset="-122"/>
                 <a:cs typeface="Calibri" pitchFamily="34" charset="-120"/>
               </a:rPr>
-              <a:t>Route Cost Map   </a:t>
+              <a:t>Fleet Penetration Simulator   </a:t>
             </a:r>
             <a:pPr indent="0" marL="0">
               <a:buNone/>
@@ -13573,7 +13484,7 @@
                 <a:ea typeface="Calibri" pitchFamily="34" charset="-122"/>
                 <a:cs typeface="Calibri" pitchFamily="34" charset="-120"/>
               </a:rPr>
-              <a:t>Still being built</a:t>
+              <a:t>National fleet projections</a:t>
             </a:r>
             <a:endParaRPr lang="en-US" sz="1150" dirty="0"/>
           </a:p>
@@ -13680,7 +13591,7 @@
                 <a:ea typeface="Calibri" pitchFamily="34" charset="-122"/>
                 <a:cs typeface="Calibri" pitchFamily="34" charset="-120"/>
               </a:rPr>
-              <a:t>Fleet Penetration Simulator   </a:t>
+              <a:t>Emissions Impact Calculator   </a:t>
             </a:r>
             <a:pPr indent="0" marL="0">
               <a:buNone/>
@@ -13694,7 +13605,7 @@
                 <a:ea typeface="Calibri" pitchFamily="34" charset="-122"/>
                 <a:cs typeface="Calibri" pitchFamily="34" charset="-120"/>
               </a:rPr>
-              <a:t>National fleet projections</a:t>
+              <a:t>CO2 for one vehicle</a:t>
             </a:r>
             <a:endParaRPr lang="en-US" sz="1150" dirty="0"/>
           </a:p>
@@ -13777,127 +13688,6 @@
         <p:spPr>
           <a:xfrm>
             <a:off x="905256" y="5614416"/>
-            <a:ext cx="5120640" cy="365760"/>
-          </a:xfrm>
-          <a:prstGeom prst="rect">
-            <a:avLst/>
-          </a:prstGeom>
-          <a:noFill/>
-          <a:ln/>
-        </p:spPr>
-        <p:txBody>
-          <a:bodyPr wrap="square" lIns="0" tIns="0" rIns="0" bIns="0" rtlCol="0" anchor="ctr"/>
-          <a:lstStyle/>
-          <a:p>
-            <a:pPr indent="0" marL="0">
-              <a:buNone/>
-            </a:pPr>
-            <a:r>
-              <a:rPr lang="en-US" sz="1150" b="1" dirty="0">
-                <a:solidFill>
-                  <a:srgbClr val="0E2A24"/>
-                </a:solidFill>
-                <a:latin typeface="Calibri" pitchFamily="34" charset="0"/>
-                <a:ea typeface="Calibri" pitchFamily="34" charset="-122"/>
-                <a:cs typeface="Calibri" pitchFamily="34" charset="-120"/>
-              </a:rPr>
-              <a:t>Emissions Impact Calculator   </a:t>
-            </a:r>
-            <a:pPr indent="0" marL="0">
-              <a:buNone/>
-            </a:pPr>
-            <a:r>
-              <a:rPr lang="en-US" sz="1150" dirty="0">
-                <a:solidFill>
-                  <a:srgbClr val="6B7A77"/>
-                </a:solidFill>
-                <a:latin typeface="Calibri" pitchFamily="34" charset="0"/>
-                <a:ea typeface="Calibri" pitchFamily="34" charset="-122"/>
-                <a:cs typeface="Calibri" pitchFamily="34" charset="-120"/>
-              </a:rPr>
-              <a:t>CO2 for one vehicle</a:t>
-            </a:r>
-            <a:endParaRPr lang="en-US" sz="1150" dirty="0"/>
-          </a:p>
-        </p:txBody>
-      </p:sp>
-      <p:sp>
-        <p:nvSpPr>
-          <p:cNvPr id="35" name="Shape 33"/>
-          <p:cNvSpPr/>
-          <p:nvPr/>
-        </p:nvSpPr>
-        <p:spPr>
-          <a:xfrm>
-            <a:off x="6172200" y="5650992"/>
-            <a:ext cx="292608" cy="292608"/>
-          </a:xfrm>
-          <a:prstGeom prst="ellipse">
-            <a:avLst/>
-          </a:prstGeom>
-          <a:solidFill>
-            <a:srgbClr val="C55A11"/>
-          </a:solidFill>
-          <a:ln w="12700">
-            <a:solidFill>
-              <a:srgbClr val="C55A11"/>
-            </a:solidFill>
-            <a:prstDash val="solid"/>
-          </a:ln>
-        </p:spPr>
-        <p:txBody>
-          <a:bodyPr/>
-          <a:p/>
-        </p:txBody>
-      </p:sp>
-      <p:sp>
-        <p:nvSpPr>
-          <p:cNvPr id="36" name="Text 34"/>
-          <p:cNvSpPr/>
-          <p:nvPr/>
-        </p:nvSpPr>
-        <p:spPr>
-          <a:xfrm>
-            <a:off x="6172200" y="5650992"/>
-            <a:ext cx="292608" cy="292608"/>
-          </a:xfrm>
-          <a:prstGeom prst="rect">
-            <a:avLst/>
-          </a:prstGeom>
-          <a:noFill/>
-          <a:ln/>
-        </p:spPr>
-        <p:txBody>
-          <a:bodyPr wrap="square" lIns="0" tIns="0" rIns="0" bIns="0" rtlCol="0" anchor="ctr"/>
-          <a:lstStyle/>
-          <a:p>
-            <a:pPr algn="ctr" indent="0" marL="0">
-              <a:buNone/>
-            </a:pPr>
-            <a:r>
-              <a:rPr lang="en-US" sz="1150" b="1" dirty="0">
-                <a:solidFill>
-                  <a:srgbClr val="FFFFFF"/>
-                </a:solidFill>
-                <a:latin typeface="Calibri" pitchFamily="34" charset="0"/>
-                <a:ea typeface="Calibri" pitchFamily="34" charset="-122"/>
-                <a:cs typeface="Calibri" pitchFamily="34" charset="-120"/>
-              </a:rPr>
-              <a:t>8</a:t>
-            </a:r>
-            <a:endParaRPr lang="en-US" sz="1150" dirty="0"/>
-          </a:p>
-        </p:txBody>
-      </p:sp>
-      <p:sp>
-        <p:nvSpPr>
-          <p:cNvPr id="37" name="Text 35"/>
-          <p:cNvSpPr/>
-          <p:nvPr/>
-        </p:nvSpPr>
-        <p:spPr>
-          <a:xfrm>
-            <a:off x="6574536" y="5614416"/>
             <a:ext cx="5120640" cy="365760"/>
           </a:xfrm>
           <a:prstGeom prst="rect">
@@ -17415,327 +17205,6 @@
               <a:t>Jamaica EV Dashboard - User Guide</a:t>
             </a:r>
             <a:endParaRPr lang="en-US" sz="900" dirty="0"/>
-          </a:p>
-        </p:txBody>
-      </p:sp>
-    </p:spTree>
-  </p:cSld>
-  <p:clrMapOvr>
-    <a:masterClrMapping/>
-  </p:clrMapOvr>
-</p:sld>
-</file>
-
-<file path=ppt/slides/slide23.xml><?xml version="1.0" encoding="utf-8"?>
-<p:sld xmlns:a="http://schemas.openxmlformats.org/drawingml/2006/main" xmlns:r="http://schemas.openxmlformats.org/officeDocument/2006/relationships" xmlns:p="http://schemas.openxmlformats.org/presentationml/2006/main">
-  <p:cSld name="Slide 23">
-    <p:bg>
-      <p:bgPr>
-        <a:solidFill>
-          <a:srgbClr val="0E2A24"/>
-        </a:solidFill>
-      </p:bgPr>
-    </p:bg>
-    <p:spTree>
-      <p:nvGrpSpPr>
-        <p:cNvPr id="1" name=""/>
-        <p:cNvGrpSpPr/>
-        <p:nvPr/>
-      </p:nvGrpSpPr>
-      <p:grpSpPr>
-        <a:xfrm>
-          <a:off x="0" y="0"/>
-          <a:ext cx="0" cy="0"/>
-          <a:chOff x="0" y="0"/>
-          <a:chExt cx="0" cy="0"/>
-        </a:xfrm>
-      </p:grpSpPr>
-      <p:sp>
-        <p:nvSpPr>
-          <p:cNvPr id="2" name="Shape 0"/>
-          <p:cNvSpPr/>
-          <p:nvPr/>
-        </p:nvSpPr>
-        <p:spPr>
-          <a:xfrm>
-            <a:off x="822960" y="2286000"/>
-            <a:ext cx="1371600" cy="1371600"/>
-          </a:xfrm>
-          <a:prstGeom prst="roundRect">
-            <a:avLst>
-              <a:gd name="adj" fmla="val 6667"/>
-            </a:avLst>
-          </a:prstGeom>
-          <a:solidFill>
-            <a:srgbClr val="2A4A42"/>
-          </a:solidFill>
-          <a:ln w="19050">
-            <a:solidFill>
-              <a:srgbClr val="3E6259"/>
-            </a:solidFill>
-            <a:prstDash val="dash"/>
-          </a:ln>
-        </p:spPr>
-        <p:txBody>
-          <a:bodyPr/>
-          <a:p/>
-        </p:txBody>
-      </p:sp>
-      <p:sp>
-        <p:nvSpPr>
-          <p:cNvPr id="3" name="Text 1"/>
-          <p:cNvSpPr/>
-          <p:nvPr/>
-        </p:nvSpPr>
-        <p:spPr>
-          <a:xfrm>
-            <a:off x="822960" y="2286000"/>
-            <a:ext cx="1371600" cy="1371600"/>
-          </a:xfrm>
-          <a:prstGeom prst="rect">
-            <a:avLst/>
-          </a:prstGeom>
-          <a:noFill/>
-          <a:ln/>
-        </p:spPr>
-        <p:txBody>
-          <a:bodyPr wrap="square" lIns="0" tIns="0" rIns="0" bIns="0" rtlCol="0" anchor="ctr"/>
-          <a:lstStyle/>
-          <a:p>
-            <a:pPr algn="ctr" indent="0" marL="0">
-              <a:buNone/>
-            </a:pPr>
-            <a:r>
-              <a:rPr lang="en-US" sz="6200" b="1" dirty="0">
-                <a:solidFill>
-                  <a:srgbClr val="7FA69C"/>
-                </a:solidFill>
-                <a:latin typeface="Cambria" pitchFamily="34" charset="0"/>
-                <a:ea typeface="Cambria" pitchFamily="34" charset="-122"/>
-                <a:cs typeface="Cambria" pitchFamily="34" charset="-120"/>
-              </a:rPr>
-              <a:t>5</a:t>
-            </a:r>
-            <a:endParaRPr lang="en-US" sz="6200" dirty="0"/>
-          </a:p>
-        </p:txBody>
-      </p:sp>
-      <p:sp>
-        <p:nvSpPr>
-          <p:cNvPr id="4" name="Text 2"/>
-          <p:cNvSpPr/>
-          <p:nvPr/>
-        </p:nvSpPr>
-        <p:spPr>
-          <a:xfrm>
-            <a:off x="2514600" y="2331720"/>
-            <a:ext cx="8686800" cy="292608"/>
-          </a:xfrm>
-          <a:prstGeom prst="rect">
-            <a:avLst/>
-          </a:prstGeom>
-          <a:noFill/>
-          <a:ln/>
-        </p:spPr>
-        <p:txBody>
-          <a:bodyPr wrap="square" lIns="0" tIns="0" rIns="0" bIns="0" rtlCol="0" anchor="ctr"/>
-          <a:lstStyle/>
-          <a:p>
-            <a:pPr indent="0" marL="0">
-              <a:buNone/>
-            </a:pPr>
-            <a:r>
-              <a:rPr lang="en-US" sz="1200" b="1" spc="200" kern="0" dirty="0">
-                <a:solidFill>
-                  <a:srgbClr val="7FA69C"/>
-                </a:solidFill>
-                <a:latin typeface="Calibri" pitchFamily="34" charset="0"/>
-                <a:ea typeface="Calibri" pitchFamily="34" charset="-122"/>
-                <a:cs typeface="Calibri" pitchFamily="34" charset="-120"/>
-              </a:rPr>
-              <a:t>MODULE 5</a:t>
-            </a:r>
-            <a:endParaRPr lang="en-US" sz="1200" dirty="0"/>
-          </a:p>
-        </p:txBody>
-      </p:sp>
-      <p:sp>
-        <p:nvSpPr>
-          <p:cNvPr id="5" name="Text 3"/>
-          <p:cNvSpPr/>
-          <p:nvPr/>
-        </p:nvSpPr>
-        <p:spPr>
-          <a:xfrm>
-            <a:off x="2514600" y="2624328"/>
-            <a:ext cx="9052560" cy="640080"/>
-          </a:xfrm>
-          <a:prstGeom prst="rect">
-            <a:avLst/>
-          </a:prstGeom>
-          <a:noFill/>
-          <a:ln/>
-        </p:spPr>
-        <p:txBody>
-          <a:bodyPr wrap="square" lIns="0" tIns="0" rIns="0" bIns="0" rtlCol="0" anchor="ctr"/>
-          <a:lstStyle/>
-          <a:p>
-            <a:pPr indent="0" marL="0">
-              <a:buNone/>
-            </a:pPr>
-            <a:r>
-              <a:rPr lang="en-US" sz="3400" b="1" dirty="0">
-                <a:solidFill>
-                  <a:srgbClr val="FFFFFF"/>
-                </a:solidFill>
-                <a:latin typeface="Cambria" pitchFamily="34" charset="0"/>
-                <a:ea typeface="Cambria" pitchFamily="34" charset="-122"/>
-                <a:cs typeface="Cambria" pitchFamily="34" charset="-120"/>
-              </a:rPr>
-              <a:t>Route Cost Map</a:t>
-            </a:r>
-            <a:endParaRPr lang="en-US" sz="3400" dirty="0"/>
-          </a:p>
-        </p:txBody>
-      </p:sp>
-      <p:sp>
-        <p:nvSpPr>
-          <p:cNvPr id="6" name="Shape 4"/>
-          <p:cNvSpPr/>
-          <p:nvPr/>
-        </p:nvSpPr>
-        <p:spPr>
-          <a:xfrm>
-            <a:off x="2542032" y="3401568"/>
-            <a:ext cx="2377440" cy="384048"/>
-          </a:xfrm>
-          <a:prstGeom prst="roundRect">
-            <a:avLst>
-              <a:gd name="adj" fmla="val 19048"/>
-            </a:avLst>
-          </a:prstGeom>
-          <a:solidFill>
-            <a:srgbClr val="3E6259"/>
-          </a:solidFill>
-          <a:ln w="12700">
-            <a:solidFill>
-              <a:srgbClr val="3E6259"/>
-            </a:solidFill>
-            <a:prstDash val="solid"/>
-          </a:ln>
-        </p:spPr>
-        <p:txBody>
-          <a:bodyPr/>
-          <a:p/>
-        </p:txBody>
-      </p:sp>
-      <p:sp>
-        <p:nvSpPr>
-          <p:cNvPr id="7" name="Text 5"/>
-          <p:cNvSpPr/>
-          <p:nvPr/>
-        </p:nvSpPr>
-        <p:spPr>
-          <a:xfrm>
-            <a:off x="2542032" y="3401568"/>
-            <a:ext cx="2377440" cy="384048"/>
-          </a:xfrm>
-          <a:prstGeom prst="rect">
-            <a:avLst/>
-          </a:prstGeom>
-          <a:noFill/>
-          <a:ln/>
-        </p:spPr>
-        <p:txBody>
-          <a:bodyPr wrap="square" lIns="0" tIns="0" rIns="0" bIns="0" rtlCol="0" anchor="ctr"/>
-          <a:lstStyle/>
-          <a:p>
-            <a:pPr algn="ctr" indent="0" marL="0">
-              <a:buNone/>
-            </a:pPr>
-            <a:r>
-              <a:rPr lang="en-US" sz="1100" b="1" spc="100" kern="0" dirty="0">
-                <a:solidFill>
-                  <a:srgbClr val="FFFFFF"/>
-                </a:solidFill>
-                <a:latin typeface="Calibri" pitchFamily="34" charset="0"/>
-                <a:ea typeface="Calibri" pitchFamily="34" charset="-122"/>
-                <a:cs typeface="Calibri" pitchFamily="34" charset="-120"/>
-              </a:rPr>
-              <a:t>TO BE COMPLETED</a:t>
-            </a:r>
-            <a:endParaRPr lang="en-US" sz="1100" dirty="0"/>
-          </a:p>
-        </p:txBody>
-      </p:sp>
-      <p:sp>
-        <p:nvSpPr>
-          <p:cNvPr id="8" name="Text 6"/>
-          <p:cNvSpPr/>
-          <p:nvPr/>
-        </p:nvSpPr>
-        <p:spPr>
-          <a:xfrm>
-            <a:off x="2542032" y="3950208"/>
-            <a:ext cx="8138160" cy="1097280"/>
-          </a:xfrm>
-          <a:prstGeom prst="rect">
-            <a:avLst/>
-          </a:prstGeom>
-          <a:noFill/>
-          <a:ln/>
-        </p:spPr>
-        <p:txBody>
-          <a:bodyPr wrap="square" lIns="0" tIns="0" rIns="0" bIns="0" rtlCol="0" anchor="ctr"/>
-          <a:lstStyle/>
-          <a:p>
-            <a:pPr indent="0" marL="0">
-              <a:lnSpc>
-                <a:spcPct val="130000"/>
-              </a:lnSpc>
-              <a:buNone/>
-            </a:pPr>
-            <a:r>
-              <a:rPr lang="en-US" sz="1400" dirty="0">
-                <a:solidFill>
-                  <a:srgbClr val="A9C6BF"/>
-                </a:solidFill>
-                <a:latin typeface="Calibri" pitchFamily="34" charset="0"/>
-                <a:ea typeface="Calibri" pitchFamily="34" charset="-122"/>
-                <a:cs typeface="Calibri" pitchFamily="34" charset="-120"/>
-              </a:rPr>
-              <a:t>This page is still being built. It appears in the sidebar and on the home page with a faded card, and opening it shows a short placeholder message.</a:t>
-            </a:r>
-            <a:endParaRPr lang="en-US" sz="1400" dirty="0"/>
-          </a:p>
-          <a:p>
-            <a:pPr indent="0" marL="0">
-              <a:lnSpc>
-                <a:spcPct val="130000"/>
-              </a:lnSpc>
-              <a:buNone/>
-            </a:pPr>
-            <a:endParaRPr lang="en-US" sz="1400" dirty="0"/>
-          </a:p>
-          <a:p>
-            <a:pPr indent="0" marL="0">
-              <a:lnSpc>
-                <a:spcPct val="130000"/>
-              </a:lnSpc>
-              <a:buNone/>
-            </a:pPr>
-            <a:r>
-              <a:rPr lang="en-US" sz="1400" dirty="0">
-                <a:solidFill>
-                  <a:srgbClr val="A9C6BF"/>
-                </a:solidFill>
-                <a:latin typeface="Calibri" pitchFamily="34" charset="0"/>
-                <a:ea typeface="Calibri" pitchFamily="34" charset="-122"/>
-                <a:cs typeface="Calibri" pitchFamily="34" charset="-120"/>
-              </a:rPr>
-              <a:t>Instructions will be added to this guide once the page is finished.</a:t>
-            </a:r>
-            <a:endParaRPr lang="en-US" sz="1400" dirty="0"/>
           </a:p>
         </p:txBody>
       </p:sp>
@@ -17835,7 +17304,7 @@
                 <a:ea typeface="Cambria" pitchFamily="34" charset="-122"/>
                 <a:cs typeface="Cambria" pitchFamily="34" charset="-120"/>
               </a:rPr>
-              <a:t>6</a:t>
+              <a:t>5</a:t>
             </a:r>
             <a:endParaRPr lang="en-US" sz="6200" dirty="0"/>
           </a:p>
@@ -17874,7 +17343,7 @@
                 <a:ea typeface="Calibri" pitchFamily="34" charset="-122"/>
                 <a:cs typeface="Calibri" pitchFamily="34" charset="-120"/>
               </a:rPr>
-              <a:t>MODULE 6</a:t>
+              <a:t>MODULE 5</a:t>
             </a:r>
             <a:endParaRPr lang="en-US" sz="1200" dirty="0"/>
           </a:p>
@@ -18055,7 +17524,7 @@
                 <a:ea typeface="Calibri" pitchFamily="34" charset="-122"/>
                 <a:cs typeface="Calibri" pitchFamily="34" charset="-120"/>
               </a:rPr>
-              <a:t>MODULE 6</a:t>
+              <a:t>MODULE 5</a:t>
             </a:r>
             <a:endParaRPr lang="en-US" sz="1100" dirty="0"/>
           </a:p>
@@ -19201,7 +18670,7 @@
                 <a:ea typeface="Calibri" pitchFamily="34" charset="-122"/>
                 <a:cs typeface="Calibri" pitchFamily="34" charset="-120"/>
               </a:rPr>
-              <a:t>Module 6 - Fleet Penetration Simulator</a:t>
+              <a:t>Module 5 - Fleet Penetration Simulator</a:t>
             </a:r>
             <a:endParaRPr lang="en-US" sz="900" dirty="0"/>
           </a:p>
@@ -19304,7 +18773,7 @@
                 <a:ea typeface="Calibri" pitchFamily="34" charset="-122"/>
                 <a:cs typeface="Calibri" pitchFamily="34" charset="-120"/>
               </a:rPr>
-              <a:t>MODULE 6</a:t>
+              <a:t>MODULE 5</a:t>
             </a:r>
             <a:endParaRPr lang="en-US" sz="1100" dirty="0"/>
           </a:p>
@@ -20397,7 +19866,7 @@
                 <a:ea typeface="Calibri" pitchFamily="34" charset="-122"/>
                 <a:cs typeface="Calibri" pitchFamily="34" charset="-120"/>
               </a:rPr>
-              <a:t>Module 6 - Fleet Penetration Simulator</a:t>
+              <a:t>Module 5 - Fleet Penetration Simulator</a:t>
             </a:r>
             <a:endParaRPr lang="en-US" sz="900" dirty="0"/>
           </a:p>
@@ -20500,7 +19969,7 @@
                 <a:ea typeface="Calibri" pitchFamily="34" charset="-122"/>
                 <a:cs typeface="Calibri" pitchFamily="34" charset="-120"/>
               </a:rPr>
-              <a:t>MODULE 6</a:t>
+              <a:t>MODULE 5</a:t>
             </a:r>
             <a:endParaRPr lang="en-US" sz="1100" dirty="0"/>
           </a:p>
@@ -21638,7 +21107,7 @@
                 <a:ea typeface="Calibri" pitchFamily="34" charset="-122"/>
                 <a:cs typeface="Calibri" pitchFamily="34" charset="-120"/>
               </a:rPr>
-              <a:t>Module 6 - Fleet Penetration Simulator</a:t>
+              <a:t>Module 5 - Fleet Penetration Simulator</a:t>
             </a:r>
             <a:endParaRPr lang="en-US" sz="900" dirty="0"/>
           </a:p>
@@ -21779,7 +21248,7 @@
                 <a:ea typeface="Cambria" pitchFamily="34" charset="-122"/>
                 <a:cs typeface="Cambria" pitchFamily="34" charset="-120"/>
               </a:rPr>
-              <a:t>7</a:t>
+              <a:t>6</a:t>
             </a:r>
             <a:endParaRPr lang="en-US" sz="6200" dirty="0"/>
           </a:p>
@@ -21818,7 +21287,7 @@
                 <a:ea typeface="Calibri" pitchFamily="34" charset="-122"/>
                 <a:cs typeface="Calibri" pitchFamily="34" charset="-120"/>
               </a:rPr>
-              <a:t>MODULE 7</a:t>
+              <a:t>MODULE 6</a:t>
             </a:r>
             <a:endParaRPr lang="en-US" sz="1200" dirty="0"/>
           </a:p>
@@ -21999,7 +21468,7 @@
                 <a:ea typeface="Calibri" pitchFamily="34" charset="-122"/>
                 <a:cs typeface="Calibri" pitchFamily="34" charset="-120"/>
               </a:rPr>
-              <a:t>MODULE 7</a:t>
+              <a:t>MODULE 6</a:t>
             </a:r>
             <a:endParaRPr lang="en-US" sz="1100" dirty="0"/>
           </a:p>
@@ -23238,7 +22707,7 @@
                 <a:ea typeface="Calibri" pitchFamily="34" charset="-122"/>
                 <a:cs typeface="Calibri" pitchFamily="34" charset="-120"/>
               </a:rPr>
-              <a:t>Module 7 - Emissions Impact Calculator</a:t>
+              <a:t>Module 6 - Emissions Impact Calculator</a:t>
             </a:r>
             <a:endParaRPr lang="en-US" sz="900" dirty="0"/>
           </a:p>
@@ -24647,7 +24116,7 @@
                 <a:ea typeface="Calibri" pitchFamily="34" charset="-122"/>
                 <a:cs typeface="Calibri" pitchFamily="34" charset="-120"/>
               </a:rPr>
-              <a:t>MODULE 7</a:t>
+              <a:t>MODULE 6</a:t>
             </a:r>
             <a:endParaRPr lang="en-US" sz="1100" dirty="0"/>
           </a:p>
@@ -25479,7 +24948,7 @@
                 <a:ea typeface="Calibri" pitchFamily="34" charset="-122"/>
                 <a:cs typeface="Calibri" pitchFamily="34" charset="-120"/>
               </a:rPr>
-              <a:t>Module 7 - Emissions Impact Calculator</a:t>
+              <a:t>Module 6 - Emissions Impact Calculator</a:t>
             </a:r>
             <a:endParaRPr lang="en-US" sz="900" dirty="0"/>
           </a:p>
@@ -25620,7 +25089,7 @@
                 <a:ea typeface="Cambria" pitchFamily="34" charset="-122"/>
                 <a:cs typeface="Cambria" pitchFamily="34" charset="-120"/>
               </a:rPr>
-              <a:t>8</a:t>
+              <a:t>7</a:t>
             </a:r>
             <a:endParaRPr lang="en-US" sz="6200" dirty="0"/>
           </a:p>
@@ -25659,7 +25128,7 @@
                 <a:ea typeface="Calibri" pitchFamily="34" charset="-122"/>
                 <a:cs typeface="Calibri" pitchFamily="34" charset="-120"/>
               </a:rPr>
-              <a:t>MODULE 8</a:t>
+              <a:t>MODULE 7</a:t>
             </a:r>
             <a:endParaRPr lang="en-US" sz="1200" dirty="0"/>
           </a:p>
@@ -25840,7 +25309,7 @@
                 <a:ea typeface="Calibri" pitchFamily="34" charset="-122"/>
                 <a:cs typeface="Calibri" pitchFamily="34" charset="-120"/>
               </a:rPr>
-              <a:t>MODULE 8</a:t>
+              <a:t>MODULE 7</a:t>
             </a:r>
             <a:endParaRPr lang="en-US" sz="1100" dirty="0"/>
           </a:p>
@@ -26210,7 +25679,7 @@
                 <a:ea typeface="Calibri" pitchFamily="34" charset="-122"/>
                 <a:cs typeface="Calibri" pitchFamily="34" charset="-120"/>
               </a:rPr>
-              <a:t>Click '8. Gas &amp; Energy Price Tracker' in the sidebar.</a:t>
+              <a:t>Click '7. Gas &amp; Energy Price Tracker' in the sidebar.</a:t>
             </a:r>
             <a:endParaRPr lang="en-US" sz="1150" dirty="0"/>
           </a:p>
@@ -27097,7 +26566,7 @@
                 <a:ea typeface="Calibri" pitchFamily="34" charset="-122"/>
                 <a:cs typeface="Calibri" pitchFamily="34" charset="-120"/>
               </a:rPr>
-              <a:t>Module 8 - Gas &amp; Energy Price Tracker</a:t>
+              <a:t>Module 7 - Gas &amp; Energy Price Tracker</a:t>
             </a:r>
             <a:endParaRPr lang="en-US" sz="900" dirty="0"/>
           </a:p>
@@ -28045,7 +27514,7 @@
                 <a:ea typeface="Calibri" pitchFamily="34" charset="-122"/>
                 <a:cs typeface="Calibri" pitchFamily="34" charset="-120"/>
               </a:rPr>
-              <a:t>set Global settings before using Modules 3, 4, 7 and 8. Everything else follows from those prices.</a:t>
+              <a:t>set Global settings before using Modules 3, 4, 6 and 7. Everything else follows from those prices.</a:t>
             </a:r>
             <a:endParaRPr lang="en-US" sz="1100" dirty="0"/>
           </a:p>
@@ -28632,7 +28101,7 @@
                 <a:ea typeface="Calibri" pitchFamily="34" charset="-122"/>
                 <a:cs typeface="Calibri" pitchFamily="34" charset="-120"/>
               </a:rPr>
-              <a:t>Try Module 7, emissions</a:t>
+              <a:t>Try Module 6, emissions</a:t>
             </a:r>
             <a:endParaRPr lang="en-US" sz="1500" dirty="0"/>
           </a:p>
@@ -28924,7 +28393,7 @@
                 <a:ea typeface="Calibri" pitchFamily="34" charset="-122"/>
                 <a:cs typeface="Calibri" pitchFamily="34" charset="-120"/>
               </a:rPr>
-              <a:t>Explore Modules 4, 6 and 8</a:t>
+              <a:t>Explore Modules 4, 5 and 7</a:t>
             </a:r>
             <a:endParaRPr lang="en-US" sz="1500" dirty="0"/>
           </a:p>
@@ -29144,7 +28613,7 @@
                 <a:ea typeface="Calibri" pitchFamily="34" charset="-122"/>
                 <a:cs typeface="Calibri" pitchFamily="34" charset="-120"/>
               </a:rPr>
-              <a:t>Every page shares the same three areas. Once you know these, all eight modules work the same way.</a:t>
+              <a:t>Every page shares the same three areas. Once you know these, all seven modules work the same way.</a:t>
             </a:r>
             <a:endParaRPr lang="en-US" sz="1300" dirty="0"/>
           </a:p>
@@ -30083,7 +29552,7 @@
                 <a:ea typeface="Calibri" pitchFamily="34" charset="-122"/>
                 <a:cs typeface="Calibri" pitchFamily="34" charset="-120"/>
               </a:rPr>
-              <a:t>It shows one card for each of the eight pages in the dashboard.</a:t>
+              <a:t>It shows one card for each of the seven pages in the dashboard.</a:t>
             </a:r>
             <a:endParaRPr lang="en-US" sz="1150" dirty="0"/>
           </a:p>
@@ -30807,7 +30276,7 @@
                 <a:ea typeface="Calibri" pitchFamily="34" charset="-122"/>
                 <a:cs typeface="Calibri" pitchFamily="34" charset="-120"/>
               </a:rPr>
-              <a:t>The home page showing all eight module cards</a:t>
+              <a:t>The home page showing all seven module cards</a:t>
             </a:r>
             <a:endParaRPr lang="en-US" sz="1250" dirty="0"/>
           </a:p>

</xml_diff>